<commit_message>
build: rebuild decks A and C and both NotebookLM corpora after provenance merge
</commit_message>
<xml_diff>
--- a/docs/Presentation-2026-May/BIMGUARD_FMP_A_Galvanic_Corrosion.pptx
+++ b/docs/Presentation-2026-May/BIMGUARD_FMP_A_Galvanic_Corrosion.pptx
@@ -7009,7 +7009,7 @@
                 </a:solidFill>
                 <a:latin typeface="Calibri"/>
               </a:rPr>
-              <a:t>A documented, reproducible method for interrogating electrochemical risk from IFC metadata alone, with every threshold traceable to a cited standard clause.</a:t>
+              <a:t>A documented, reproducible method for interrogating electrochemical risk from IFC metadata alone, with every threshold tied to the standard governing its mechanism. The threshold values are authored calibration, not quoted from those standards.</a:t>
             </a:r>
           </a:p>
         </p:txBody>
@@ -9906,7 +9906,7 @@
                 </a:solidFill>
                 <a:latin typeface="Calibri"/>
               </a:rPr>
-              <a:t>Every threshold traces to a cited source</a:t>
+              <a:t>Standards governing each mechanism; the thresholds are authored calibration</a:t>
             </a:r>
           </a:p>
         </p:txBody>
@@ -10155,7 +10155,7 @@
                 </a:solidFill>
                 <a:latin typeface="Calibri"/>
               </a:rPr>
-              <a:t>What it supplies</a:t>
+              <a:t>Mechanism addressed</a:t>
             </a:r>
           </a:p>
         </p:txBody>

</xml_diff>